<commit_message>
added spatial resolution to the doc website
</commit_message>
<xml_diff>
--- a/pySEAFOM_updates.pptx
+++ b/pySEAFOM_updates.pptx
@@ -126,7 +126,7 @@
 <file path=ppt/revisionInfo.xml><?xml version="1.0" encoding="utf-8"?>
 <p1510:revInfo xmlns:a="http://schemas.openxmlformats.org/drawingml/2006/main" xmlns:r="http://schemas.openxmlformats.org/officeDocument/2006/relationships" xmlns:p1510="http://schemas.microsoft.com/office/powerpoint/2015/10/main">
   <p1510:revLst>
-    <p1510:client id="{C2F2CB6F-16AD-4657-ABB9-2079F8BF5977}" v="177" dt="2026-02-20T12:43:51.878"/>
+    <p1510:client id="{C2F2CB6F-16AD-4657-ABB9-2079F8BF5977}" v="208" dt="2026-03-21T10:37:32.589"/>
   </p1510:revLst>
 </p1510:revInfo>
 </file>
@@ -214,6 +214,46 @@
     </pc:docChg>
   </pc:docChgLst>
   <pc:docChgLst>
+    <pc:chgData name="Moradi, Peyman" userId="dba91eb0-4a36-42e9-bb56-2c55a234965d" providerId="ADAL" clId="{206DAC3E-7CBD-49A7-B112-27788DC86FDE}"/>
+    <pc:docChg chg="modSld">
+      <pc:chgData name="Moradi, Peyman" userId="dba91eb0-4a36-42e9-bb56-2c55a234965d" providerId="ADAL" clId="{206DAC3E-7CBD-49A7-B112-27788DC86FDE}" dt="2026-03-21T10:37:32.589" v="31" actId="108"/>
+      <pc:docMkLst>
+        <pc:docMk/>
+      </pc:docMkLst>
+      <pc:sldChg chg="modSp mod">
+        <pc:chgData name="Moradi, Peyman" userId="dba91eb0-4a36-42e9-bb56-2c55a234965d" providerId="ADAL" clId="{206DAC3E-7CBD-49A7-B112-27788DC86FDE}" dt="2026-03-21T10:37:32.589" v="31" actId="108"/>
+        <pc:sldMkLst>
+          <pc:docMk/>
+          <pc:sldMk cId="348206209" sldId="259"/>
+        </pc:sldMkLst>
+        <pc:grpChg chg="mod">
+          <ac:chgData name="Moradi, Peyman" userId="dba91eb0-4a36-42e9-bb56-2c55a234965d" providerId="ADAL" clId="{206DAC3E-7CBD-49A7-B112-27788DC86FDE}" dt="2026-03-21T10:36:52.525" v="14" actId="1076"/>
+          <ac:grpSpMkLst>
+            <pc:docMk/>
+            <pc:sldMk cId="348206209" sldId="259"/>
+            <ac:grpSpMk id="3" creationId="{B4216EDE-9EFB-A14A-81F7-A698B9A65E2A}"/>
+          </ac:grpSpMkLst>
+        </pc:grpChg>
+        <pc:graphicFrameChg chg="mod modGraphic">
+          <ac:chgData name="Moradi, Peyman" userId="dba91eb0-4a36-42e9-bb56-2c55a234965d" providerId="ADAL" clId="{206DAC3E-7CBD-49A7-B112-27788DC86FDE}" dt="2026-03-21T10:37:32.589" v="31" actId="108"/>
+          <ac:graphicFrameMkLst>
+            <pc:docMk/>
+            <pc:sldMk cId="348206209" sldId="259"/>
+            <ac:graphicFrameMk id="10" creationId="{04FFF0D5-86E4-BFB4-A048-E34CF6C0B9DB}"/>
+          </ac:graphicFrameMkLst>
+        </pc:graphicFrameChg>
+        <pc:picChg chg="mod">
+          <ac:chgData name="Moradi, Peyman" userId="dba91eb0-4a36-42e9-bb56-2c55a234965d" providerId="ADAL" clId="{206DAC3E-7CBD-49A7-B112-27788DC86FDE}" dt="2026-03-21T10:36:52.525" v="14" actId="1076"/>
+          <ac:picMkLst>
+            <pc:docMk/>
+            <pc:sldMk cId="348206209" sldId="259"/>
+            <ac:picMk id="1032" creationId="{DD8C88D5-2ECC-586E-F688-6577B864EA43}"/>
+          </ac:picMkLst>
+        </pc:picChg>
+      </pc:sldChg>
+    </pc:docChg>
+  </pc:docChgLst>
+  <pc:docChgLst>
     <pc:chgData name="Moradi, Peyman" userId="dba91eb0-4a36-42e9-bb56-2c55a234965d" providerId="ADAL" clId="{C2F2CB6F-16AD-4657-ABB9-2079F8BF5977}"/>
     <pc:docChg chg="undo custSel addSld modSld sldOrd modMainMaster">
       <pc:chgData name="Moradi, Peyman" userId="dba91eb0-4a36-42e9-bb56-2c55a234965d" providerId="ADAL" clId="{C2F2CB6F-16AD-4657-ABB9-2079F8BF5977}" dt="2026-02-20T12:45:22.766" v="333" actId="20577"/>
@@ -241,14 +281,6 @@
           <pc:docMk/>
           <pc:sldMk cId="3609631159" sldId="258"/>
         </pc:sldMkLst>
-        <pc:picChg chg="add mod">
-          <ac:chgData name="Moradi, Peyman" userId="dba91eb0-4a36-42e9-bb56-2c55a234965d" providerId="ADAL" clId="{C2F2CB6F-16AD-4657-ABB9-2079F8BF5977}" dt="2026-02-20T12:30:49.170" v="90"/>
-          <ac:picMkLst>
-            <pc:docMk/>
-            <pc:sldMk cId="3609631159" sldId="258"/>
-            <ac:picMk id="2" creationId="{3DB1111D-0211-AA57-F873-67C51840D33B}"/>
-          </ac:picMkLst>
-        </pc:picChg>
       </pc:sldChg>
       <pc:sldChg chg="addSp delSp modSp mod">
         <pc:chgData name="Moradi, Peyman" userId="dba91eb0-4a36-42e9-bb56-2c55a234965d" providerId="ADAL" clId="{C2F2CB6F-16AD-4657-ABB9-2079F8BF5977}" dt="2026-02-20T12:45:22.766" v="333" actId="20577"/>
@@ -280,14 +312,6 @@
             <ac:grpSpMk id="3" creationId="{B4216EDE-9EFB-A14A-81F7-A698B9A65E2A}"/>
           </ac:grpSpMkLst>
         </pc:grpChg>
-        <pc:graphicFrameChg chg="del">
-          <ac:chgData name="Moradi, Peyman" userId="dba91eb0-4a36-42e9-bb56-2c55a234965d" providerId="ADAL" clId="{C2F2CB6F-16AD-4657-ABB9-2079F8BF5977}" dt="2026-02-20T12:37:42.577" v="211" actId="478"/>
-          <ac:graphicFrameMkLst>
-            <pc:docMk/>
-            <pc:sldMk cId="348206209" sldId="259"/>
-            <ac:graphicFrameMk id="9" creationId="{AC6D72F3-4A60-50F7-4E1A-41769F30B1FC}"/>
-          </ac:graphicFrameMkLst>
-        </pc:graphicFrameChg>
         <pc:graphicFrameChg chg="mod modGraphic">
           <ac:chgData name="Moradi, Peyman" userId="dba91eb0-4a36-42e9-bb56-2c55a234965d" providerId="ADAL" clId="{C2F2CB6F-16AD-4657-ABB9-2079F8BF5977}" dt="2026-02-20T12:37:58.751" v="216" actId="164"/>
           <ac:graphicFrameMkLst>
@@ -296,14 +320,6 @@
             <ac:graphicFrameMk id="10" creationId="{04FFF0D5-86E4-BFB4-A048-E34CF6C0B9DB}"/>
           </ac:graphicFrameMkLst>
         </pc:graphicFrameChg>
-        <pc:picChg chg="add del mod">
-          <ac:chgData name="Moradi, Peyman" userId="dba91eb0-4a36-42e9-bb56-2c55a234965d" providerId="ADAL" clId="{C2F2CB6F-16AD-4657-ABB9-2079F8BF5977}" dt="2026-02-20T12:37:43.243" v="212" actId="478"/>
-          <ac:picMkLst>
-            <pc:docMk/>
-            <pc:sldMk cId="348206209" sldId="259"/>
-            <ac:picMk id="5" creationId="{4F541BD6-DD7D-990B-BC10-2FFD4339654B}"/>
-          </ac:picMkLst>
-        </pc:picChg>
         <pc:picChg chg="mod">
           <ac:chgData name="Moradi, Peyman" userId="dba91eb0-4a36-42e9-bb56-2c55a234965d" providerId="ADAL" clId="{C2F2CB6F-16AD-4657-ABB9-2079F8BF5977}" dt="2026-02-20T12:37:58.751" v="216" actId="164"/>
           <ac:picMkLst>
@@ -404,14 +420,6 @@
             <ac:picMk id="5" creationId="{E30F6090-A84F-85AE-E70C-A9A21187BF9A}"/>
           </ac:picMkLst>
         </pc:picChg>
-        <pc:picChg chg="del mod">
-          <ac:chgData name="Moradi, Peyman" userId="dba91eb0-4a36-42e9-bb56-2c55a234965d" providerId="ADAL" clId="{C2F2CB6F-16AD-4657-ABB9-2079F8BF5977}" dt="2026-02-20T12:34:14.819" v="114" actId="478"/>
-          <ac:picMkLst>
-            <pc:docMk/>
-            <pc:sldMk cId="178843416" sldId="264"/>
-            <ac:picMk id="7" creationId="{06750C7B-352F-E1D2-7698-7F93851933A5}"/>
-          </ac:picMkLst>
-        </pc:picChg>
       </pc:sldChg>
       <pc:sldChg chg="ord">
         <pc:chgData name="Moradi, Peyman" userId="dba91eb0-4a36-42e9-bb56-2c55a234965d" providerId="ADAL" clId="{C2F2CB6F-16AD-4657-ABB9-2079F8BF5977}" dt="2026-02-20T12:43:41.534" v="313"/>
@@ -441,14 +449,6 @@
           <pc:docMk/>
           <pc:sldMk cId="1785318421" sldId="267"/>
         </pc:sldMkLst>
-        <pc:spChg chg="add del">
-          <ac:chgData name="Moradi, Peyman" userId="dba91eb0-4a36-42e9-bb56-2c55a234965d" providerId="ADAL" clId="{C2F2CB6F-16AD-4657-ABB9-2079F8BF5977}" dt="2026-02-20T12:38:55.301" v="233" actId="478"/>
-          <ac:spMkLst>
-            <pc:docMk/>
-            <pc:sldMk cId="1785318421" sldId="267"/>
-            <ac:spMk id="2" creationId="{AA18AC7E-51BC-2890-B748-4ED5CE587E17}"/>
-          </ac:spMkLst>
-        </pc:spChg>
         <pc:spChg chg="mod">
           <ac:chgData name="Moradi, Peyman" userId="dba91eb0-4a36-42e9-bb56-2c55a234965d" providerId="ADAL" clId="{C2F2CB6F-16AD-4657-ABB9-2079F8BF5977}" dt="2026-02-20T12:44:58.328" v="326" actId="403"/>
           <ac:spMkLst>
@@ -465,30 +465,6 @@
             <ac:graphicFrameMk id="9" creationId="{F4A65CC7-2DFA-3E51-4EFD-5E4E7CF17266}"/>
           </ac:graphicFrameMkLst>
         </pc:graphicFrameChg>
-        <pc:graphicFrameChg chg="del">
-          <ac:chgData name="Moradi, Peyman" userId="dba91eb0-4a36-42e9-bb56-2c55a234965d" providerId="ADAL" clId="{C2F2CB6F-16AD-4657-ABB9-2079F8BF5977}" dt="2026-02-20T12:38:03.230" v="217" actId="478"/>
-          <ac:graphicFrameMkLst>
-            <pc:docMk/>
-            <pc:sldMk cId="1785318421" sldId="267"/>
-            <ac:graphicFrameMk id="10" creationId="{40290919-E4E5-C19C-AF5E-E36CB7648FD5}"/>
-          </ac:graphicFrameMkLst>
-        </pc:graphicFrameChg>
-        <pc:picChg chg="add del">
-          <ac:chgData name="Moradi, Peyman" userId="dba91eb0-4a36-42e9-bb56-2c55a234965d" providerId="ADAL" clId="{C2F2CB6F-16AD-4657-ABB9-2079F8BF5977}" dt="2026-02-20T12:40:22.692" v="275" actId="478"/>
-          <ac:picMkLst>
-            <pc:docMk/>
-            <pc:sldMk cId="1785318421" sldId="267"/>
-            <ac:picMk id="5" creationId="{A01A39A7-DDB4-159F-7BC6-6E6613A701DC}"/>
-          </ac:picMkLst>
-        </pc:picChg>
-        <pc:picChg chg="del">
-          <ac:chgData name="Moradi, Peyman" userId="dba91eb0-4a36-42e9-bb56-2c55a234965d" providerId="ADAL" clId="{C2F2CB6F-16AD-4657-ABB9-2079F8BF5977}" dt="2026-02-20T12:38:05.190" v="218" actId="478"/>
-          <ac:picMkLst>
-            <pc:docMk/>
-            <pc:sldMk cId="1785318421" sldId="267"/>
-            <ac:picMk id="1032" creationId="{F5AA8EDC-5700-570A-AA6C-FB6E17CF3858}"/>
-          </ac:picMkLst>
-        </pc:picChg>
       </pc:sldChg>
       <pc:sldChg chg="addSp delSp modSp new mod">
         <pc:chgData name="Moradi, Peyman" userId="dba91eb0-4a36-42e9-bb56-2c55a234965d" providerId="ADAL" clId="{C2F2CB6F-16AD-4657-ABB9-2079F8BF5977}" dt="2026-02-20T12:43:55.950" v="324" actId="478"/>
@@ -496,36 +472,12 @@
           <pc:docMk/>
           <pc:sldMk cId="2192517749" sldId="268"/>
         </pc:sldMkLst>
-        <pc:spChg chg="del mod">
-          <ac:chgData name="Moradi, Peyman" userId="dba91eb0-4a36-42e9-bb56-2c55a234965d" providerId="ADAL" clId="{C2F2CB6F-16AD-4657-ABB9-2079F8BF5977}" dt="2026-02-20T12:43:53.787" v="322" actId="478"/>
-          <ac:spMkLst>
-            <pc:docMk/>
-            <pc:sldMk cId="2192517749" sldId="268"/>
-            <ac:spMk id="2" creationId="{E89043BA-38FD-8AD1-092F-D56136FD1FE2}"/>
-          </ac:spMkLst>
-        </pc:spChg>
-        <pc:spChg chg="del">
-          <ac:chgData name="Moradi, Peyman" userId="dba91eb0-4a36-42e9-bb56-2c55a234965d" providerId="ADAL" clId="{C2F2CB6F-16AD-4657-ABB9-2079F8BF5977}" dt="2026-02-20T12:43:55.347" v="323" actId="478"/>
-          <ac:spMkLst>
-            <pc:docMk/>
-            <pc:sldMk cId="2192517749" sldId="268"/>
-            <ac:spMk id="3" creationId="{2EE4F911-9A81-91D6-CD82-54EDF6A6FF58}"/>
-          </ac:spMkLst>
-        </pc:spChg>
         <pc:spChg chg="add mod">
           <ac:chgData name="Moradi, Peyman" userId="dba91eb0-4a36-42e9-bb56-2c55a234965d" providerId="ADAL" clId="{C2F2CB6F-16AD-4657-ABB9-2079F8BF5977}" dt="2026-02-20T12:43:51.878" v="321"/>
           <ac:spMkLst>
             <pc:docMk/>
             <pc:sldMk cId="2192517749" sldId="268"/>
             <ac:spMk id="4" creationId="{79B40E0F-6392-1FE3-D9EB-EFA9D71A09BD}"/>
-          </ac:spMkLst>
-        </pc:spChg>
-        <pc:spChg chg="add del mod">
-          <ac:chgData name="Moradi, Peyman" userId="dba91eb0-4a36-42e9-bb56-2c55a234965d" providerId="ADAL" clId="{C2F2CB6F-16AD-4657-ABB9-2079F8BF5977}" dt="2026-02-20T12:43:55.950" v="324" actId="478"/>
-          <ac:spMkLst>
-            <pc:docMk/>
-            <pc:sldMk cId="2192517749" sldId="268"/>
-            <ac:spMk id="6" creationId="{E3FD4BDD-95D8-EA5F-1D61-7B3F4A025191}"/>
           </ac:spMkLst>
         </pc:spChg>
       </pc:sldChg>
@@ -549,15 +501,6 @@
               <pc:sldMasterMk cId="4273989651" sldId="2147483648"/>
               <pc:sldLayoutMk cId="3198248103" sldId="2147483650"/>
               <ac:picMk id="7" creationId="{5E0AE5C6-C3A3-4D45-378C-0785B6B731AE}"/>
-            </ac:picMkLst>
-          </pc:picChg>
-          <pc:picChg chg="del">
-            <ac:chgData name="Moradi, Peyman" userId="dba91eb0-4a36-42e9-bb56-2c55a234965d" providerId="ADAL" clId="{C2F2CB6F-16AD-4657-ABB9-2079F8BF5977}" dt="2026-02-20T12:32:05.883" v="101" actId="478"/>
-            <ac:picMkLst>
-              <pc:docMk/>
-              <pc:sldMasterMk cId="4273989651" sldId="2147483648"/>
-              <pc:sldLayoutMk cId="3198248103" sldId="2147483650"/>
-              <ac:picMk id="9" creationId="{E066B403-E53F-84A8-0496-B2EE581A01C4}"/>
             </ac:picMkLst>
           </pc:picChg>
         </pc:sldLayoutChg>
@@ -7433,7 +7376,14 @@
             <a:buNone/>
           </a:pPr>
           <a:r>
-            <a:rPr lang="en-US" sz="1400" b="0" i="0" kern="1200" dirty="0"/>
+            <a:rPr lang="en-US" sz="1800" b="1" i="0" kern="1200" dirty="0">
+              <a:solidFill>
+                <a:prstClr val="white"/>
+              </a:solidFill>
+              <a:latin typeface="Amasis MT Pro Black" panose="020F0502020204030204" pitchFamily="18" charset="0"/>
+              <a:ea typeface="+mn-ea"/>
+              <a:cs typeface="+mn-cs"/>
+            </a:rPr>
             <a:t>✓</a:t>
           </a:r>
           <a:r>
@@ -7488,7 +7438,7 @@
             <a:buAutoNum type="arabicPeriod"/>
           </a:pPr>
           <a:r>
-            <a:rPr lang="en-US" sz="1400" b="1" dirty="0"/>
+            <a:rPr lang="en-US" sz="1400" b="1" kern="1200" dirty="0"/>
             <a:t>Frequency Response </a:t>
           </a:r>
         </a:p>
@@ -7498,10 +7448,16 @@
             <a:buAutoNum type="arabicPeriod"/>
           </a:pPr>
           <a:r>
-            <a:rPr lang="en-US" sz="1400" b="0" i="0" dirty="0"/>
+            <a:rPr lang="en-US" sz="1800" b="1" i="0" kern="1200" dirty="0">
+              <a:solidFill>
+                <a:prstClr val="white"/>
+              </a:solidFill>
+              <a:latin typeface="Amasis MT Pro Black" panose="020F0502020204030204" pitchFamily="18" charset="0"/>
+              <a:ea typeface="+mn-ea"/>
+              <a:cs typeface="+mn-cs"/>
+            </a:rPr>
             <a:t>✓</a:t>
           </a:r>
-          <a:endParaRPr lang="en-US" sz="1400" b="1" dirty="0"/>
         </a:p>
       </dgm:t>
     </dgm:pt>
@@ -7531,22 +7487,55 @@
       <dgm:prSet custT="1"/>
       <dgm:spPr>
         <a:solidFill>
-          <a:schemeClr val="bg2">
-            <a:lumMod val="75000"/>
-          </a:schemeClr>
+          <a:schemeClr val="accent6"/>
         </a:solidFill>
       </dgm:spPr>
       <dgm:t>
         <a:bodyPr/>
         <a:lstStyle/>
         <a:p>
-          <a:pPr>
+          <a:pPr marL="0" lvl="0" algn="ctr" defTabSz="622300">
+            <a:lnSpc>
+              <a:spcPct val="90000"/>
+            </a:lnSpc>
+            <a:spcBef>
+              <a:spcPct val="0"/>
+            </a:spcBef>
+            <a:spcAft>
+              <a:spcPct val="35000"/>
+            </a:spcAft>
             <a:buFont typeface="+mj-lt"/>
             <a:buAutoNum type="arabicPeriod"/>
           </a:pPr>
           <a:r>
-            <a:rPr lang="en-US" sz="1400" b="1" dirty="0"/>
+            <a:rPr lang="en-US" sz="1400" b="1" kern="1200" dirty="0"/>
             <a:t>Spatial Resolution </a:t>
+          </a:r>
+        </a:p>
+        <a:p>
+          <a:pPr marL="0" lvl="0" algn="ctr" defTabSz="622300">
+            <a:lnSpc>
+              <a:spcPct val="90000"/>
+            </a:lnSpc>
+            <a:spcBef>
+              <a:spcPct val="0"/>
+            </a:spcBef>
+            <a:spcAft>
+              <a:spcPct val="35000"/>
+            </a:spcAft>
+            <a:buFont typeface="+mj-lt"/>
+            <a:buNone/>
+          </a:pPr>
+          <a:r>
+            <a:rPr lang="en-US" sz="1800" b="1" i="0" kern="1200" dirty="0">
+              <a:solidFill>
+                <a:prstClr val="white"/>
+              </a:solidFill>
+              <a:latin typeface="Amasis MT Pro Black" panose="020F0502020204030204" pitchFamily="18" charset="0"/>
+              <a:ea typeface="+mn-ea"/>
+              <a:cs typeface="+mn-cs"/>
+            </a:rPr>
+            <a:t>✓</a:t>
           </a:r>
         </a:p>
       </dgm:t>
@@ -7593,10 +7582,14 @@
             <a:t>Self Noise </a:t>
           </a:r>
           <a:r>
-            <a:rPr lang="en-US" sz="1400" b="0" i="0" dirty="0"/>
+            <a:rPr lang="en-US" sz="1800" b="1" i="0" dirty="0">
+              <a:latin typeface="Amasis MT Pro Black" panose="020F0502020204030204" pitchFamily="18" charset="0"/>
+            </a:rPr>
             <a:t>✓</a:t>
           </a:r>
-          <a:endParaRPr lang="en-US" sz="1400" b="1" dirty="0"/>
+          <a:endParaRPr lang="en-US" sz="1400" b="1" dirty="0">
+            <a:latin typeface="Amasis MT Pro Black" panose="020F0502020204030204" pitchFamily="18" charset="0"/>
+          </a:endParaRPr>
         </a:p>
       </dgm:t>
     </dgm:pt>
@@ -7638,7 +7631,7 @@
             <a:buAutoNum type="arabicPeriod"/>
           </a:pPr>
           <a:r>
-            <a:rPr lang="en-US" sz="1400" b="1" dirty="0"/>
+            <a:rPr lang="en-US" sz="1400" b="1" kern="1200" dirty="0"/>
             <a:t>Loss Budget</a:t>
           </a:r>
         </a:p>
@@ -7648,11 +7641,18 @@
             <a:buAutoNum type="arabicPeriod"/>
           </a:pPr>
           <a:r>
-            <a:rPr lang="en-US" sz="1400" b="0" i="0" dirty="0"/>
+            <a:rPr lang="en-US" sz="1800" b="1" i="0" kern="1200" dirty="0">
+              <a:solidFill>
+                <a:prstClr val="white"/>
+              </a:solidFill>
+              <a:latin typeface="Amasis MT Pro Black" panose="020F0502020204030204" pitchFamily="18" charset="0"/>
+              <a:ea typeface="+mn-ea"/>
+              <a:cs typeface="+mn-cs"/>
+            </a:rPr>
             <a:t>✓</a:t>
           </a:r>
           <a:r>
-            <a:rPr lang="en-US" sz="1400" b="1" dirty="0"/>
+            <a:rPr lang="en-US" sz="1400" b="1" kern="1200" dirty="0"/>
             <a:t> </a:t>
           </a:r>
         </a:p>
@@ -7744,17 +7744,16 @@
             <a:buNone/>
           </a:pPr>
           <a:r>
-            <a:rPr lang="en-US" sz="1400" b="0" i="0" kern="1200" dirty="0"/>
+            <a:rPr lang="en-US" sz="1800" b="1" i="0" kern="1200" dirty="0">
+              <a:solidFill>
+                <a:prstClr val="white"/>
+              </a:solidFill>
+              <a:latin typeface="Amasis MT Pro Black" panose="020F0502020204030204" pitchFamily="18" charset="0"/>
+              <a:ea typeface="+mn-ea"/>
+              <a:cs typeface="+mn-cs"/>
+            </a:rPr>
             <a:t>✓</a:t>
           </a:r>
-          <a:endParaRPr lang="en-US" sz="1400" b="1" kern="1200" dirty="0">
-            <a:solidFill>
-              <a:prstClr val="white"/>
-            </a:solidFill>
-            <a:latin typeface="Aptos" panose="02110004020202020204"/>
-            <a:ea typeface="+mn-ea"/>
-            <a:cs typeface="+mn-cs"/>
-          </a:endParaRPr>
         </a:p>
       </dgm:t>
     </dgm:pt>
@@ -7844,7 +7843,14 @@
             <a:buNone/>
           </a:pPr>
           <a:r>
-            <a:rPr lang="en-US" sz="1400" b="0" i="0" kern="1200" dirty="0"/>
+            <a:rPr lang="en-US" sz="1800" b="1" i="0" kern="1200" dirty="0">
+              <a:solidFill>
+                <a:prstClr val="white"/>
+              </a:solidFill>
+              <a:latin typeface="Amasis MT Pro Black" panose="020F0502020204030204" pitchFamily="18" charset="0"/>
+              <a:ea typeface="+mn-ea"/>
+              <a:cs typeface="+mn-cs"/>
+            </a:rPr>
             <a:t>✓</a:t>
           </a:r>
           <a:r>
@@ -7883,6 +7889,52 @@
         </a:p>
       </dgm:t>
     </dgm:pt>
+    <dgm:pt modelId="{2BA55374-8309-4101-9186-84CA35B46176}">
+      <dgm:prSet custT="1"/>
+      <dgm:spPr>
+        <a:solidFill>
+          <a:schemeClr val="bg1">
+            <a:lumMod val="75000"/>
+          </a:schemeClr>
+        </a:solidFill>
+      </dgm:spPr>
+      <dgm:t>
+        <a:bodyPr/>
+        <a:lstStyle/>
+        <a:p>
+          <a:pPr>
+            <a:buFont typeface="+mj-lt"/>
+            <a:buAutoNum type="arabicPeriod"/>
+          </a:pPr>
+          <a:r>
+            <a:rPr lang="en-US" sz="1400" b="1" dirty="0"/>
+            <a:t>LF DAS</a:t>
+          </a:r>
+        </a:p>
+      </dgm:t>
+    </dgm:pt>
+    <dgm:pt modelId="{F5351BC1-5585-42AC-9E6D-29B5692B7929}" type="parTrans" cxnId="{6DA93C85-6D09-4D15-BC53-09364F5B02C5}">
+      <dgm:prSet/>
+      <dgm:spPr/>
+      <dgm:t>
+        <a:bodyPr/>
+        <a:lstStyle/>
+        <a:p>
+          <a:endParaRPr lang="en-US"/>
+        </a:p>
+      </dgm:t>
+    </dgm:pt>
+    <dgm:pt modelId="{1045FAEF-CEDA-44F5-B7FB-2C70DC6F865A}" type="sibTrans" cxnId="{6DA93C85-6D09-4D15-BC53-09364F5B02C5}">
+      <dgm:prSet/>
+      <dgm:spPr/>
+      <dgm:t>
+        <a:bodyPr/>
+        <a:lstStyle/>
+        <a:p>
+          <a:endParaRPr lang="en-US"/>
+        </a:p>
+      </dgm:t>
+    </dgm:pt>
     <dgm:pt modelId="{B282CD55-80AA-4736-94EB-595F4BA0CA63}" type="pres">
       <dgm:prSet presAssocID="{5CB66685-683C-4DF0-8AB4-3FD46DD78B5A}" presName="cycle" presStyleCnt="0">
         <dgm:presLayoutVars>
@@ -7899,15 +7951,15 @@
       <dgm:spPr/>
     </dgm:pt>
     <dgm:pt modelId="{A5500CA8-E1AC-4EA2-84FF-778CCAFF54E5}" type="pres">
-      <dgm:prSet presAssocID="{56529125-8434-4C93-921F-7E52EBD6AC44}" presName="Name9" presStyleLbl="parChTrans1D2" presStyleIdx="0" presStyleCnt="7"/>
+      <dgm:prSet presAssocID="{56529125-8434-4C93-921F-7E52EBD6AC44}" presName="Name9" presStyleLbl="parChTrans1D2" presStyleIdx="0" presStyleCnt="8"/>
       <dgm:spPr/>
     </dgm:pt>
     <dgm:pt modelId="{52197289-1EFF-4DFD-8359-D848E03FF289}" type="pres">
-      <dgm:prSet presAssocID="{56529125-8434-4C93-921F-7E52EBD6AC44}" presName="connTx" presStyleLbl="parChTrans1D2" presStyleIdx="0" presStyleCnt="7"/>
+      <dgm:prSet presAssocID="{56529125-8434-4C93-921F-7E52EBD6AC44}" presName="connTx" presStyleLbl="parChTrans1D2" presStyleIdx="0" presStyleCnt="8"/>
       <dgm:spPr/>
     </dgm:pt>
     <dgm:pt modelId="{D641129D-BF39-4F22-BF56-9E2A62EAEF7C}" type="pres">
-      <dgm:prSet presAssocID="{F11269FF-AE4B-4E34-AD0E-37A12D1B3070}" presName="node" presStyleLbl="node1" presStyleIdx="0" presStyleCnt="7">
+      <dgm:prSet presAssocID="{F11269FF-AE4B-4E34-AD0E-37A12D1B3070}" presName="node" presStyleLbl="node1" presStyleIdx="0" presStyleCnt="8">
         <dgm:presLayoutVars>
           <dgm:bulletEnabled val="1"/>
         </dgm:presLayoutVars>
@@ -7915,15 +7967,15 @@
       <dgm:spPr/>
     </dgm:pt>
     <dgm:pt modelId="{60E69F3E-8134-4538-A3EF-3F6FEA683E0F}" type="pres">
-      <dgm:prSet presAssocID="{AC75B354-EAB7-44F9-A1F5-C819F398FE79}" presName="Name9" presStyleLbl="parChTrans1D2" presStyleIdx="1" presStyleCnt="7"/>
+      <dgm:prSet presAssocID="{AC75B354-EAB7-44F9-A1F5-C819F398FE79}" presName="Name9" presStyleLbl="parChTrans1D2" presStyleIdx="1" presStyleCnt="8"/>
       <dgm:spPr/>
     </dgm:pt>
     <dgm:pt modelId="{6E93971E-9A9F-4D69-AA4E-0592A2D29FE4}" type="pres">
-      <dgm:prSet presAssocID="{AC75B354-EAB7-44F9-A1F5-C819F398FE79}" presName="connTx" presStyleLbl="parChTrans1D2" presStyleIdx="1" presStyleCnt="7"/>
+      <dgm:prSet presAssocID="{AC75B354-EAB7-44F9-A1F5-C819F398FE79}" presName="connTx" presStyleLbl="parChTrans1D2" presStyleIdx="1" presStyleCnt="8"/>
       <dgm:spPr/>
     </dgm:pt>
     <dgm:pt modelId="{C29E633D-FDB3-4A03-AF0D-B36013E3D45B}" type="pres">
-      <dgm:prSet presAssocID="{9276693D-18BD-4E6A-98A8-CD3AC8A0169F}" presName="node" presStyleLbl="node1" presStyleIdx="1" presStyleCnt="7">
+      <dgm:prSet presAssocID="{9276693D-18BD-4E6A-98A8-CD3AC8A0169F}" presName="node" presStyleLbl="node1" presStyleIdx="1" presStyleCnt="8">
         <dgm:presLayoutVars>
           <dgm:bulletEnabled val="1"/>
         </dgm:presLayoutVars>
@@ -7931,15 +7983,15 @@
       <dgm:spPr/>
     </dgm:pt>
     <dgm:pt modelId="{3C3F841D-B84E-439D-A70D-DACE222F23B4}" type="pres">
-      <dgm:prSet presAssocID="{4251F846-A5D6-4502-A172-7C452AF5EACD}" presName="Name9" presStyleLbl="parChTrans1D2" presStyleIdx="2" presStyleCnt="7"/>
+      <dgm:prSet presAssocID="{4251F846-A5D6-4502-A172-7C452AF5EACD}" presName="Name9" presStyleLbl="parChTrans1D2" presStyleIdx="2" presStyleCnt="8"/>
       <dgm:spPr/>
     </dgm:pt>
     <dgm:pt modelId="{406C70AC-63CB-46A2-A134-1D284C5603F3}" type="pres">
-      <dgm:prSet presAssocID="{4251F846-A5D6-4502-A172-7C452AF5EACD}" presName="connTx" presStyleLbl="parChTrans1D2" presStyleIdx="2" presStyleCnt="7"/>
+      <dgm:prSet presAssocID="{4251F846-A5D6-4502-A172-7C452AF5EACD}" presName="connTx" presStyleLbl="parChTrans1D2" presStyleIdx="2" presStyleCnt="8"/>
       <dgm:spPr/>
     </dgm:pt>
     <dgm:pt modelId="{CB79E053-F38E-4A67-BA83-A4800638DD26}" type="pres">
-      <dgm:prSet presAssocID="{D169CF8C-37F4-4D3C-B839-17BE92F2A6E9}" presName="node" presStyleLbl="node1" presStyleIdx="2" presStyleCnt="7">
+      <dgm:prSet presAssocID="{D169CF8C-37F4-4D3C-B839-17BE92F2A6E9}" presName="node" presStyleLbl="node1" presStyleIdx="2" presStyleCnt="8">
         <dgm:presLayoutVars>
           <dgm:bulletEnabled val="1"/>
         </dgm:presLayoutVars>
@@ -7955,15 +8007,15 @@
       </dgm:spPr>
     </dgm:pt>
     <dgm:pt modelId="{21F3E271-E659-4F2A-B5D3-98DDE2FF03DA}" type="pres">
-      <dgm:prSet presAssocID="{50EF01FF-9F4A-44BE-AF75-01ADE32A4BD1}" presName="Name9" presStyleLbl="parChTrans1D2" presStyleIdx="3" presStyleCnt="7"/>
+      <dgm:prSet presAssocID="{50EF01FF-9F4A-44BE-AF75-01ADE32A4BD1}" presName="Name9" presStyleLbl="parChTrans1D2" presStyleIdx="3" presStyleCnt="8"/>
       <dgm:spPr/>
     </dgm:pt>
     <dgm:pt modelId="{AA77F63E-918B-4155-9BFC-21717E1E4A68}" type="pres">
-      <dgm:prSet presAssocID="{50EF01FF-9F4A-44BE-AF75-01ADE32A4BD1}" presName="connTx" presStyleLbl="parChTrans1D2" presStyleIdx="3" presStyleCnt="7"/>
+      <dgm:prSet presAssocID="{50EF01FF-9F4A-44BE-AF75-01ADE32A4BD1}" presName="connTx" presStyleLbl="parChTrans1D2" presStyleIdx="3" presStyleCnt="8"/>
       <dgm:spPr/>
     </dgm:pt>
     <dgm:pt modelId="{381951C3-DC69-4329-A787-F6F20281D3F6}" type="pres">
-      <dgm:prSet presAssocID="{0AAC9302-6561-4DEF-82F8-2F08F6FCB9E7}" presName="node" presStyleLbl="node1" presStyleIdx="3" presStyleCnt="7">
+      <dgm:prSet presAssocID="{0AAC9302-6561-4DEF-82F8-2F08F6FCB9E7}" presName="node" presStyleLbl="node1" presStyleIdx="3" presStyleCnt="8">
         <dgm:presLayoutVars>
           <dgm:bulletEnabled val="1"/>
         </dgm:presLayoutVars>
@@ -7979,15 +8031,15 @@
       </dgm:spPr>
     </dgm:pt>
     <dgm:pt modelId="{97AB2DA7-3196-4812-85DB-C0730E66FABE}" type="pres">
-      <dgm:prSet presAssocID="{289487A0-EA96-456F-9739-128913BC60F7}" presName="Name9" presStyleLbl="parChTrans1D2" presStyleIdx="4" presStyleCnt="7"/>
+      <dgm:prSet presAssocID="{289487A0-EA96-456F-9739-128913BC60F7}" presName="Name9" presStyleLbl="parChTrans1D2" presStyleIdx="4" presStyleCnt="8"/>
       <dgm:spPr/>
     </dgm:pt>
     <dgm:pt modelId="{F5FCA264-2A39-4DAD-9B2A-A854A053E783}" type="pres">
-      <dgm:prSet presAssocID="{289487A0-EA96-456F-9739-128913BC60F7}" presName="connTx" presStyleLbl="parChTrans1D2" presStyleIdx="4" presStyleCnt="7"/>
+      <dgm:prSet presAssocID="{289487A0-EA96-456F-9739-128913BC60F7}" presName="connTx" presStyleLbl="parChTrans1D2" presStyleIdx="4" presStyleCnt="8"/>
       <dgm:spPr/>
     </dgm:pt>
     <dgm:pt modelId="{13F65213-867A-4369-9543-F3799FB5E0F8}" type="pres">
-      <dgm:prSet presAssocID="{5F80989D-4BBF-474F-AA54-878ABB0C0F60}" presName="node" presStyleLbl="node1" presStyleIdx="4" presStyleCnt="7">
+      <dgm:prSet presAssocID="{5F80989D-4BBF-474F-AA54-878ABB0C0F60}" presName="node" presStyleLbl="node1" presStyleIdx="4" presStyleCnt="8">
         <dgm:presLayoutVars>
           <dgm:bulletEnabled val="1"/>
         </dgm:presLayoutVars>
@@ -8003,15 +8055,15 @@
       </dgm:spPr>
     </dgm:pt>
     <dgm:pt modelId="{18CBF4D6-765C-4365-B23D-911EEF96DF4B}" type="pres">
-      <dgm:prSet presAssocID="{7E89B98A-1A8B-490B-9141-C5866B0A59E6}" presName="Name9" presStyleLbl="parChTrans1D2" presStyleIdx="5" presStyleCnt="7"/>
+      <dgm:prSet presAssocID="{7E89B98A-1A8B-490B-9141-C5866B0A59E6}" presName="Name9" presStyleLbl="parChTrans1D2" presStyleIdx="5" presStyleCnt="8"/>
       <dgm:spPr/>
     </dgm:pt>
     <dgm:pt modelId="{DCA37DC1-8E0B-4D17-87B9-4DD7390141DB}" type="pres">
-      <dgm:prSet presAssocID="{7E89B98A-1A8B-490B-9141-C5866B0A59E6}" presName="connTx" presStyleLbl="parChTrans1D2" presStyleIdx="5" presStyleCnt="7"/>
+      <dgm:prSet presAssocID="{7E89B98A-1A8B-490B-9141-C5866B0A59E6}" presName="connTx" presStyleLbl="parChTrans1D2" presStyleIdx="5" presStyleCnt="8"/>
       <dgm:spPr/>
     </dgm:pt>
     <dgm:pt modelId="{8726FD26-0446-4A34-A789-F609EFF6B576}" type="pres">
-      <dgm:prSet presAssocID="{EA1DB194-0418-4CBC-A71D-38D26681E52F}" presName="node" presStyleLbl="node1" presStyleIdx="5" presStyleCnt="7">
+      <dgm:prSet presAssocID="{EA1DB194-0418-4CBC-A71D-38D26681E52F}" presName="node" presStyleLbl="node1" presStyleIdx="5" presStyleCnt="8">
         <dgm:presLayoutVars>
           <dgm:bulletEnabled val="1"/>
         </dgm:presLayoutVars>
@@ -8019,15 +8071,31 @@
       <dgm:spPr/>
     </dgm:pt>
     <dgm:pt modelId="{0B890D38-9A63-42F6-B391-F93CB128C0AE}" type="pres">
-      <dgm:prSet presAssocID="{D0949D85-B545-4504-A7DC-E57327AD8B4D}" presName="Name9" presStyleLbl="parChTrans1D2" presStyleIdx="6" presStyleCnt="7"/>
+      <dgm:prSet presAssocID="{D0949D85-B545-4504-A7DC-E57327AD8B4D}" presName="Name9" presStyleLbl="parChTrans1D2" presStyleIdx="6" presStyleCnt="8"/>
       <dgm:spPr/>
     </dgm:pt>
     <dgm:pt modelId="{D5893B7E-6692-4C02-8564-ECC24D44F21B}" type="pres">
-      <dgm:prSet presAssocID="{D0949D85-B545-4504-A7DC-E57327AD8B4D}" presName="connTx" presStyleLbl="parChTrans1D2" presStyleIdx="6" presStyleCnt="7"/>
+      <dgm:prSet presAssocID="{D0949D85-B545-4504-A7DC-E57327AD8B4D}" presName="connTx" presStyleLbl="parChTrans1D2" presStyleIdx="6" presStyleCnt="8"/>
       <dgm:spPr/>
     </dgm:pt>
     <dgm:pt modelId="{01EEE674-D7A4-44BB-95E6-EEE4B45DB353}" type="pres">
-      <dgm:prSet presAssocID="{5AE3CAE3-FE28-43AE-BE4A-8BCBE734CEE7}" presName="node" presStyleLbl="node1" presStyleIdx="6" presStyleCnt="7">
+      <dgm:prSet presAssocID="{5AE3CAE3-FE28-43AE-BE4A-8BCBE734CEE7}" presName="node" presStyleLbl="node1" presStyleIdx="6" presStyleCnt="8">
+        <dgm:presLayoutVars>
+          <dgm:bulletEnabled val="1"/>
+        </dgm:presLayoutVars>
+      </dgm:prSet>
+      <dgm:spPr/>
+    </dgm:pt>
+    <dgm:pt modelId="{3B9E1353-2632-4497-81E7-C879A35F94AC}" type="pres">
+      <dgm:prSet presAssocID="{F5351BC1-5585-42AC-9E6D-29B5692B7929}" presName="Name9" presStyleLbl="parChTrans1D2" presStyleIdx="7" presStyleCnt="8"/>
+      <dgm:spPr/>
+    </dgm:pt>
+    <dgm:pt modelId="{66CAC345-B6CA-4B31-8EC6-C36D08782BE2}" type="pres">
+      <dgm:prSet presAssocID="{F5351BC1-5585-42AC-9E6D-29B5692B7929}" presName="connTx" presStyleLbl="parChTrans1D2" presStyleIdx="7" presStyleCnt="8"/>
+      <dgm:spPr/>
+    </dgm:pt>
+    <dgm:pt modelId="{53DB598F-3538-45FC-A34A-6E2175D70F64}" type="pres">
+      <dgm:prSet presAssocID="{2BA55374-8309-4101-9186-84CA35B46176}" presName="node" presStyleLbl="node1" presStyleIdx="7" presStyleCnt="8">
         <dgm:presLayoutVars>
           <dgm:bulletEnabled val="1"/>
         </dgm:presLayoutVars>
@@ -8039,6 +8107,7 @@
     <dgm:cxn modelId="{67062F00-1056-4E6B-939E-9E6A12216FDE}" srcId="{A0F00485-747B-48A5-BA46-8B953C12D208}" destId="{EA1DB194-0418-4CBC-A71D-38D26681E52F}" srcOrd="5" destOrd="0" parTransId="{7E89B98A-1A8B-490B-9141-C5866B0A59E6}" sibTransId="{C52DFD15-2C78-4952-8E58-95640A80D599}"/>
     <dgm:cxn modelId="{74F7F50C-38EC-412C-85A8-66ADD63F9E8A}" type="presOf" srcId="{D0949D85-B545-4504-A7DC-E57327AD8B4D}" destId="{0B890D38-9A63-42F6-B391-F93CB128C0AE}" srcOrd="0" destOrd="0" presId="urn:microsoft.com/office/officeart/2005/8/layout/radial1"/>
     <dgm:cxn modelId="{137A1327-7C1B-4AA9-8F9D-0DE11448C333}" type="presOf" srcId="{AC75B354-EAB7-44F9-A1F5-C819F398FE79}" destId="{6E93971E-9A9F-4D69-AA4E-0592A2D29FE4}" srcOrd="1" destOrd="0" presId="urn:microsoft.com/office/officeart/2005/8/layout/radial1"/>
+    <dgm:cxn modelId="{792ECF31-F916-4AAB-B53F-A4ED05A5EA3D}" type="presOf" srcId="{F5351BC1-5585-42AC-9E6D-29B5692B7929}" destId="{3B9E1353-2632-4497-81E7-C879A35F94AC}" srcOrd="0" destOrd="0" presId="urn:microsoft.com/office/officeart/2005/8/layout/radial1"/>
     <dgm:cxn modelId="{0843ED3A-166A-4CE4-9E2E-8FAA1974E4F7}" type="presOf" srcId="{9276693D-18BD-4E6A-98A8-CD3AC8A0169F}" destId="{C29E633D-FDB3-4A03-AF0D-B36013E3D45B}" srcOrd="0" destOrd="0" presId="urn:microsoft.com/office/officeart/2005/8/layout/radial1"/>
     <dgm:cxn modelId="{AF535C3B-733F-49F3-9E7F-F0A993ABA9AF}" srcId="{A0F00485-747B-48A5-BA46-8B953C12D208}" destId="{5F80989D-4BBF-474F-AA54-878ABB0C0F60}" srcOrd="4" destOrd="0" parTransId="{289487A0-EA96-456F-9739-128913BC60F7}" sibTransId="{4F740DBB-0ACE-4807-A96E-0F8FFB9F6FBF}"/>
     <dgm:cxn modelId="{F731FB3C-EB1A-437B-9B7E-04D5C44CC693}" type="presOf" srcId="{D0949D85-B545-4504-A7DC-E57327AD8B4D}" destId="{D5893B7E-6692-4C02-8564-ECC24D44F21B}" srcOrd="1" destOrd="0" presId="urn:microsoft.com/office/officeart/2005/8/layout/radial1"/>
@@ -8051,6 +8120,7 @@
     <dgm:cxn modelId="{E9205B4C-9F25-4180-89CB-69626C198506}" srcId="{A0F00485-747B-48A5-BA46-8B953C12D208}" destId="{F11269FF-AE4B-4E34-AD0E-37A12D1B3070}" srcOrd="0" destOrd="0" parTransId="{56529125-8434-4C93-921F-7E52EBD6AC44}" sibTransId="{EE5B9790-9664-4327-8F15-126ECF32512B}"/>
     <dgm:cxn modelId="{7E2B6371-6A06-4A0D-9E22-7DC13CFFDA28}" srcId="{A0F00485-747B-48A5-BA46-8B953C12D208}" destId="{D169CF8C-37F4-4D3C-B839-17BE92F2A6E9}" srcOrd="2" destOrd="0" parTransId="{4251F846-A5D6-4502-A172-7C452AF5EACD}" sibTransId="{CDC99734-453B-4ABC-AD9A-3B662D24AEE7}"/>
     <dgm:cxn modelId="{54099F74-5011-4E65-ADE7-8C1CD012BB18}" type="presOf" srcId="{289487A0-EA96-456F-9739-128913BC60F7}" destId="{F5FCA264-2A39-4DAD-9B2A-A854A053E783}" srcOrd="1" destOrd="0" presId="urn:microsoft.com/office/officeart/2005/8/layout/radial1"/>
+    <dgm:cxn modelId="{6DA93C85-6D09-4D15-BC53-09364F5B02C5}" srcId="{A0F00485-747B-48A5-BA46-8B953C12D208}" destId="{2BA55374-8309-4101-9186-84CA35B46176}" srcOrd="7" destOrd="0" parTransId="{F5351BC1-5585-42AC-9E6D-29B5692B7929}" sibTransId="{1045FAEF-CEDA-44F5-B7FB-2C70DC6F865A}"/>
     <dgm:cxn modelId="{4B4DE486-5150-4F19-B654-6B145458E1F0}" type="presOf" srcId="{7E89B98A-1A8B-490B-9141-C5866B0A59E6}" destId="{DCA37DC1-8E0B-4D17-87B9-4DD7390141DB}" srcOrd="1" destOrd="0" presId="urn:microsoft.com/office/officeart/2005/8/layout/radial1"/>
     <dgm:cxn modelId="{DDF88F87-0A6A-4C92-8F08-007063158EB6}" type="presOf" srcId="{5CB66685-683C-4DF0-8AB4-3FD46DD78B5A}" destId="{B282CD55-80AA-4736-94EB-595F4BA0CA63}" srcOrd="0" destOrd="0" presId="urn:microsoft.com/office/officeart/2005/8/layout/radial1"/>
     <dgm:cxn modelId="{F8759987-C014-4D4B-AE6A-8D206C44EA2A}" srcId="{5CB66685-683C-4DF0-8AB4-3FD46DD78B5A}" destId="{A0F00485-747B-48A5-BA46-8B953C12D208}" srcOrd="0" destOrd="0" parTransId="{278E96FD-817D-427D-9B8C-A14E379A75EA}" sibTransId="{B9792CD5-E8CC-48BE-9FC9-AB4A934C8308}"/>
@@ -8059,6 +8129,8 @@
     <dgm:cxn modelId="{17602798-90A6-40FA-80F7-321490EFA96E}" type="presOf" srcId="{4251F846-A5D6-4502-A172-7C452AF5EACD}" destId="{406C70AC-63CB-46A2-A134-1D284C5603F3}" srcOrd="1" destOrd="0" presId="urn:microsoft.com/office/officeart/2005/8/layout/radial1"/>
     <dgm:cxn modelId="{F239029C-BB44-4051-8662-62A1C24B64F9}" type="presOf" srcId="{4251F846-A5D6-4502-A172-7C452AF5EACD}" destId="{3C3F841D-B84E-439D-A70D-DACE222F23B4}" srcOrd="0" destOrd="0" presId="urn:microsoft.com/office/officeart/2005/8/layout/radial1"/>
     <dgm:cxn modelId="{65C4ADA4-6453-4ED0-A99C-2DBF73167821}" type="presOf" srcId="{50EF01FF-9F4A-44BE-AF75-01ADE32A4BD1}" destId="{21F3E271-E659-4F2A-B5D3-98DDE2FF03DA}" srcOrd="0" destOrd="0" presId="urn:microsoft.com/office/officeart/2005/8/layout/radial1"/>
+    <dgm:cxn modelId="{4BDF40AC-115C-4AC8-B3F9-65939DAAA2C8}" type="presOf" srcId="{2BA55374-8309-4101-9186-84CA35B46176}" destId="{53DB598F-3538-45FC-A34A-6E2175D70F64}" srcOrd="0" destOrd="0" presId="urn:microsoft.com/office/officeart/2005/8/layout/radial1"/>
+    <dgm:cxn modelId="{79A316B5-329D-483B-A121-F0DE4A73B765}" type="presOf" srcId="{F5351BC1-5585-42AC-9E6D-29B5692B7929}" destId="{66CAC345-B6CA-4B31-8EC6-C36D08782BE2}" srcOrd="1" destOrd="0" presId="urn:microsoft.com/office/officeart/2005/8/layout/radial1"/>
     <dgm:cxn modelId="{7980C2BA-4385-4229-8C4C-7BFA3EC484C4}" type="presOf" srcId="{5AE3CAE3-FE28-43AE-BE4A-8BCBE734CEE7}" destId="{01EEE674-D7A4-44BB-95E6-EEE4B45DB353}" srcOrd="0" destOrd="0" presId="urn:microsoft.com/office/officeart/2005/8/layout/radial1"/>
     <dgm:cxn modelId="{B6B4E5BD-CB8F-477C-BC8E-D303EC1BFED8}" type="presOf" srcId="{50EF01FF-9F4A-44BE-AF75-01ADE32A4BD1}" destId="{AA77F63E-918B-4155-9BFC-21717E1E4A68}" srcOrd="1" destOrd="0" presId="urn:microsoft.com/office/officeart/2005/8/layout/radial1"/>
     <dgm:cxn modelId="{ACB607CB-1027-46B0-B941-9D6C782BBBC4}" srcId="{A0F00485-747B-48A5-BA46-8B953C12D208}" destId="{0AAC9302-6561-4DEF-82F8-2F08F6FCB9E7}" srcOrd="3" destOrd="0" parTransId="{50EF01FF-9F4A-44BE-AF75-01ADE32A4BD1}" sibTransId="{04F11AFB-DBAA-4145-A497-078B1B896D4E}"/>
@@ -8089,6 +8161,9 @@
     <dgm:cxn modelId="{DEC1566C-FCF0-4668-9E34-65DEF5ABC027}" type="presParOf" srcId="{B282CD55-80AA-4736-94EB-595F4BA0CA63}" destId="{0B890D38-9A63-42F6-B391-F93CB128C0AE}" srcOrd="13" destOrd="0" presId="urn:microsoft.com/office/officeart/2005/8/layout/radial1"/>
     <dgm:cxn modelId="{666DA491-ED13-4981-8288-41E4A9880B50}" type="presParOf" srcId="{0B890D38-9A63-42F6-B391-F93CB128C0AE}" destId="{D5893B7E-6692-4C02-8564-ECC24D44F21B}" srcOrd="0" destOrd="0" presId="urn:microsoft.com/office/officeart/2005/8/layout/radial1"/>
     <dgm:cxn modelId="{9ED3238D-57A7-42B2-B37A-7CD20883CE24}" type="presParOf" srcId="{B282CD55-80AA-4736-94EB-595F4BA0CA63}" destId="{01EEE674-D7A4-44BB-95E6-EEE4B45DB353}" srcOrd="14" destOrd="0" presId="urn:microsoft.com/office/officeart/2005/8/layout/radial1"/>
+    <dgm:cxn modelId="{F75728D6-082D-4774-9AB7-39A6D656ACDB}" type="presParOf" srcId="{B282CD55-80AA-4736-94EB-595F4BA0CA63}" destId="{3B9E1353-2632-4497-81E7-C879A35F94AC}" srcOrd="15" destOrd="0" presId="urn:microsoft.com/office/officeart/2005/8/layout/radial1"/>
+    <dgm:cxn modelId="{89CFE837-AE7F-4F0B-87AA-5C93DCDAA002}" type="presParOf" srcId="{3B9E1353-2632-4497-81E7-C879A35F94AC}" destId="{66CAC345-B6CA-4B31-8EC6-C36D08782BE2}" srcOrd="0" destOrd="0" presId="urn:microsoft.com/office/officeart/2005/8/layout/radial1"/>
+    <dgm:cxn modelId="{418AB0B9-FCAF-4DF3-8978-27A0DA2C11B2}" type="presParOf" srcId="{B282CD55-80AA-4736-94EB-595F4BA0CA63}" destId="{53DB598F-3538-45FC-A34A-6E2175D70F64}" srcOrd="16" destOrd="0" presId="urn:microsoft.com/office/officeart/2005/8/layout/radial1"/>
   </dgm:cxnLst>
   <dgm:bg/>
   <dgm:whole/>
@@ -12276,8 +12351,8 @@
       </dsp:nvSpPr>
       <dsp:spPr>
         <a:xfrm>
-          <a:off x="3910636" y="2182226"/>
-          <a:ext cx="1440302" cy="1440302"/>
+          <a:off x="4185792" y="2328452"/>
+          <a:ext cx="1356269" cy="1356269"/>
         </a:xfrm>
         <a:prstGeom prst="ellipse">
           <a:avLst/>
@@ -12340,8 +12415,8 @@
         </a:p>
       </dsp:txBody>
       <dsp:txXfrm>
-        <a:off x="4121563" y="2393153"/>
-        <a:ext cx="1018448" cy="1018448"/>
+        <a:off x="4384413" y="2527073"/>
+        <a:ext cx="959027" cy="959027"/>
       </dsp:txXfrm>
     </dsp:sp>
     <dsp:sp modelId="{A5500CA8-E1AC-4EA2-84FF-778CCAFF54E5}">
@@ -12351,8 +12426,8 @@
       </dsp:nvSpPr>
       <dsp:spPr>
         <a:xfrm rot="16200000">
-          <a:off x="4270054" y="1807497"/>
-          <a:ext cx="721467" cy="27992"/>
+          <a:off x="4390211" y="1842188"/>
+          <a:ext cx="947432" cy="25095"/>
         </a:xfrm>
         <a:custGeom>
           <a:avLst/>
@@ -12363,10 +12438,10 @@
           <a:pathLst>
             <a:path>
               <a:moveTo>
-                <a:pt x="0" y="13996"/>
+                <a:pt x="0" y="12547"/>
               </a:moveTo>
               <a:lnTo>
-                <a:pt x="721467" y="13996"/>
+                <a:pt x="947432" y="12547"/>
               </a:lnTo>
             </a:path>
           </a:pathLst>
@@ -12420,8 +12495,8 @@
         </a:p>
       </dsp:txBody>
       <dsp:txXfrm>
-        <a:off x="4612751" y="1803456"/>
-        <a:ext cx="36073" cy="36073"/>
+        <a:off x="4840241" y="1831050"/>
+        <a:ext cx="47371" cy="47371"/>
       </dsp:txXfrm>
     </dsp:sp>
     <dsp:sp modelId="{D641129D-BF39-4F22-BF56-9E2A62EAEF7C}">
@@ -12431,8 +12506,8 @@
       </dsp:nvSpPr>
       <dsp:spPr>
         <a:xfrm>
-          <a:off x="3910636" y="20456"/>
-          <a:ext cx="1440302" cy="1440302"/>
+          <a:off x="4185792" y="24750"/>
+          <a:ext cx="1356269" cy="1356269"/>
         </a:xfrm>
         <a:prstGeom prst="ellipse">
           <a:avLst/>
@@ -12492,15 +12567,19 @@
             <a:t>Self Noise </a:t>
           </a:r>
           <a:r>
-            <a:rPr lang="en-US" sz="1400" b="0" i="0" kern="1200" dirty="0"/>
+            <a:rPr lang="en-US" sz="1800" b="1" i="0" kern="1200" dirty="0">
+              <a:latin typeface="Amasis MT Pro Black" panose="020F0502020204030204" pitchFamily="18" charset="0"/>
+            </a:rPr>
             <a:t>✓</a:t>
           </a:r>
-          <a:endParaRPr lang="en-US" sz="1400" b="1" kern="1200" dirty="0"/>
+          <a:endParaRPr lang="en-US" sz="1400" b="1" kern="1200" dirty="0">
+            <a:latin typeface="Amasis MT Pro Black" panose="020F0502020204030204" pitchFamily="18" charset="0"/>
+          </a:endParaRPr>
         </a:p>
       </dsp:txBody>
       <dsp:txXfrm>
-        <a:off x="4121563" y="231383"/>
-        <a:ext cx="1018448" cy="1018448"/>
+        <a:off x="4384413" y="223371"/>
+        <a:ext cx="959027" cy="959027"/>
       </dsp:txXfrm>
     </dsp:sp>
     <dsp:sp modelId="{60E69F3E-8134-4538-A3EF-3F6FEA683E0F}">
@@ -12509,9 +12588,9 @@
         <dsp:cNvSpPr/>
       </dsp:nvSpPr>
       <dsp:spPr>
-        <a:xfrm rot="19285714">
-          <a:off x="5115124" y="2214461"/>
-          <a:ext cx="721467" cy="27992"/>
+        <a:xfrm rot="18900000">
+          <a:off x="5204692" y="2179557"/>
+          <a:ext cx="947432" cy="25095"/>
         </a:xfrm>
         <a:custGeom>
           <a:avLst/>
@@ -12522,10 +12601,10 @@
           <a:pathLst>
             <a:path>
               <a:moveTo>
-                <a:pt x="0" y="13996"/>
+                <a:pt x="0" y="12547"/>
               </a:moveTo>
               <a:lnTo>
-                <a:pt x="721467" y="13996"/>
+                <a:pt x="947432" y="12547"/>
               </a:lnTo>
             </a:path>
           </a:pathLst>
@@ -12579,8 +12658,8 @@
         </a:p>
       </dsp:txBody>
       <dsp:txXfrm>
-        <a:off x="5457821" y="2210420"/>
-        <a:ext cx="36073" cy="36073"/>
+        <a:off x="5654723" y="2168420"/>
+        <a:ext cx="47371" cy="47371"/>
       </dsp:txXfrm>
     </dsp:sp>
     <dsp:sp modelId="{C29E633D-FDB3-4A03-AF0D-B36013E3D45B}">
@@ -12590,8 +12669,8 @@
       </dsp:nvSpPr>
       <dsp:spPr>
         <a:xfrm>
-          <a:off x="5600776" y="834385"/>
-          <a:ext cx="1440302" cy="1440302"/>
+          <a:off x="5814756" y="699489"/>
+          <a:ext cx="1356269" cy="1356269"/>
         </a:xfrm>
         <a:prstGeom prst="ellipse">
           <a:avLst/>
@@ -12666,7 +12745,14 @@
             <a:buNone/>
           </a:pPr>
           <a:r>
-            <a:rPr lang="en-US" sz="1400" b="0" i="0" kern="1200" dirty="0"/>
+            <a:rPr lang="en-US" sz="1800" b="1" i="0" kern="1200" dirty="0">
+              <a:solidFill>
+                <a:prstClr val="white"/>
+              </a:solidFill>
+              <a:latin typeface="Amasis MT Pro Black" panose="020F0502020204030204" pitchFamily="18" charset="0"/>
+              <a:ea typeface="+mn-ea"/>
+              <a:cs typeface="+mn-cs"/>
+            </a:rPr>
             <a:t>✓</a:t>
           </a:r>
           <a:r>
@@ -12676,8 +12762,8 @@
         </a:p>
       </dsp:txBody>
       <dsp:txXfrm>
-        <a:off x="5811703" y="1045312"/>
-        <a:ext cx="1018448" cy="1018448"/>
+        <a:off x="6013377" y="898110"/>
+        <a:ext cx="959027" cy="959027"/>
       </dsp:txXfrm>
     </dsp:sp>
     <dsp:sp modelId="{3C3F841D-B84E-439D-A70D-DACE222F23B4}">
@@ -12686,9 +12772,9 @@
         <dsp:cNvSpPr/>
       </dsp:nvSpPr>
       <dsp:spPr>
-        <a:xfrm rot="771429">
-          <a:off x="5323839" y="3128901"/>
-          <a:ext cx="721467" cy="27992"/>
+        <a:xfrm>
+          <a:off x="5542062" y="2994039"/>
+          <a:ext cx="947432" cy="25095"/>
         </a:xfrm>
         <a:custGeom>
           <a:avLst/>
@@ -12699,10 +12785,10 @@
           <a:pathLst>
             <a:path>
               <a:moveTo>
-                <a:pt x="0" y="13996"/>
+                <a:pt x="0" y="12547"/>
               </a:moveTo>
               <a:lnTo>
-                <a:pt x="721467" y="13996"/>
+                <a:pt x="947432" y="12547"/>
               </a:lnTo>
             </a:path>
           </a:pathLst>
@@ -12756,8 +12842,8 @@
         </a:p>
       </dsp:txBody>
       <dsp:txXfrm>
-        <a:off x="5666536" y="3124861"/>
-        <a:ext cx="36073" cy="36073"/>
+        <a:off x="5992092" y="2982901"/>
+        <a:ext cx="47371" cy="47371"/>
       </dsp:txXfrm>
     </dsp:sp>
     <dsp:sp modelId="{CB79E053-F38E-4A67-BA83-A4800638DD26}">
@@ -12767,8 +12853,8 @@
       </dsp:nvSpPr>
       <dsp:spPr>
         <a:xfrm>
-          <a:off x="6018206" y="2663266"/>
-          <a:ext cx="1440302" cy="1440302"/>
+          <a:off x="6489494" y="2328452"/>
+          <a:ext cx="1356269" cy="1356269"/>
         </a:xfrm>
         <a:prstGeom prst="ellipse">
           <a:avLst/>
@@ -12850,7 +12936,14 @@
             <a:buNone/>
           </a:pPr>
           <a:r>
-            <a:rPr lang="en-US" sz="1400" b="0" i="0" kern="1200" dirty="0"/>
+            <a:rPr lang="en-US" sz="1800" b="1" i="0" kern="1200" dirty="0">
+              <a:solidFill>
+                <a:prstClr val="white"/>
+              </a:solidFill>
+              <a:latin typeface="Amasis MT Pro Black" panose="020F0502020204030204" pitchFamily="18" charset="0"/>
+              <a:ea typeface="+mn-ea"/>
+              <a:cs typeface="+mn-cs"/>
+            </a:rPr>
             <a:t>✓</a:t>
           </a:r>
           <a:r>
@@ -12867,8 +12960,8 @@
         </a:p>
       </dsp:txBody>
       <dsp:txXfrm>
-        <a:off x="6229133" y="2874193"/>
-        <a:ext cx="1018448" cy="1018448"/>
+        <a:off x="6688115" y="2527073"/>
+        <a:ext cx="959027" cy="959027"/>
       </dsp:txXfrm>
     </dsp:sp>
     <dsp:sp modelId="{21F3E271-E659-4F2A-B5D3-98DDE2FF03DA}">
@@ -12877,9 +12970,9 @@
         <dsp:cNvSpPr/>
       </dsp:nvSpPr>
       <dsp:spPr>
-        <a:xfrm rot="3857143">
-          <a:off x="4739032" y="3862225"/>
-          <a:ext cx="721467" cy="27992"/>
+        <a:xfrm rot="2700000">
+          <a:off x="5204692" y="3808521"/>
+          <a:ext cx="947432" cy="25095"/>
         </a:xfrm>
         <a:custGeom>
           <a:avLst/>
@@ -12890,10 +12983,10 @@
           <a:pathLst>
             <a:path>
               <a:moveTo>
-                <a:pt x="0" y="13996"/>
+                <a:pt x="0" y="12547"/>
               </a:moveTo>
               <a:lnTo>
-                <a:pt x="721467" y="13996"/>
+                <a:pt x="947432" y="12547"/>
               </a:lnTo>
             </a:path>
           </a:pathLst>
@@ -12947,8 +13040,8 @@
         </a:p>
       </dsp:txBody>
       <dsp:txXfrm>
-        <a:off x="5081729" y="3858185"/>
-        <a:ext cx="36073" cy="36073"/>
+        <a:off x="5654723" y="3797383"/>
+        <a:ext cx="47371" cy="47371"/>
       </dsp:txXfrm>
     </dsp:sp>
     <dsp:sp modelId="{381951C3-DC69-4329-A787-F6F20281D3F6}">
@@ -12958,8 +13051,8 @@
       </dsp:nvSpPr>
       <dsp:spPr>
         <a:xfrm>
-          <a:off x="4848593" y="4129914"/>
-          <a:ext cx="1440302" cy="1440302"/>
+          <a:off x="5814756" y="3957416"/>
+          <a:ext cx="1356269" cy="1356269"/>
         </a:xfrm>
         <a:prstGeom prst="ellipse">
           <a:avLst/>
@@ -13041,22 +13134,21 @@
             <a:buNone/>
           </a:pPr>
           <a:r>
-            <a:rPr lang="en-US" sz="1400" b="0" i="0" kern="1200" dirty="0"/>
+            <a:rPr lang="en-US" sz="1800" b="1" i="0" kern="1200" dirty="0">
+              <a:solidFill>
+                <a:prstClr val="white"/>
+              </a:solidFill>
+              <a:latin typeface="Amasis MT Pro Black" panose="020F0502020204030204" pitchFamily="18" charset="0"/>
+              <a:ea typeface="+mn-ea"/>
+              <a:cs typeface="+mn-cs"/>
+            </a:rPr>
             <a:t>✓</a:t>
           </a:r>
-          <a:endParaRPr lang="en-US" sz="1400" b="1" kern="1200" dirty="0">
-            <a:solidFill>
-              <a:prstClr val="white"/>
-            </a:solidFill>
-            <a:latin typeface="Aptos" panose="02110004020202020204"/>
-            <a:ea typeface="+mn-ea"/>
-            <a:cs typeface="+mn-cs"/>
-          </a:endParaRPr>
         </a:p>
       </dsp:txBody>
       <dsp:txXfrm>
-        <a:off x="5059520" y="4340841"/>
-        <a:ext cx="1018448" cy="1018448"/>
+        <a:off x="6013377" y="4156037"/>
+        <a:ext cx="959027" cy="959027"/>
       </dsp:txXfrm>
     </dsp:sp>
     <dsp:sp modelId="{97AB2DA7-3196-4812-85DB-C0730E66FABE}">
@@ -13065,9 +13157,9 @@
         <dsp:cNvSpPr/>
       </dsp:nvSpPr>
       <dsp:spPr>
-        <a:xfrm rot="6942857">
-          <a:off x="3801075" y="3862225"/>
-          <a:ext cx="721467" cy="27992"/>
+        <a:xfrm rot="5400000">
+          <a:off x="4390211" y="4145890"/>
+          <a:ext cx="947432" cy="25095"/>
         </a:xfrm>
         <a:custGeom>
           <a:avLst/>
@@ -13078,10 +13170,10 @@
           <a:pathLst>
             <a:path>
               <a:moveTo>
-                <a:pt x="0" y="13996"/>
+                <a:pt x="0" y="12547"/>
               </a:moveTo>
               <a:lnTo>
-                <a:pt x="721467" y="13996"/>
+                <a:pt x="947432" y="12547"/>
               </a:lnTo>
             </a:path>
           </a:pathLst>
@@ -13134,9 +13226,9 @@
           <a:endParaRPr lang="en-US" sz="700" kern="1200"/>
         </a:p>
       </dsp:txBody>
-      <dsp:txXfrm rot="10800000">
-        <a:off x="4143772" y="3858185"/>
-        <a:ext cx="36073" cy="36073"/>
+      <dsp:txXfrm>
+        <a:off x="4840241" y="4134752"/>
+        <a:ext cx="47371" cy="47371"/>
       </dsp:txXfrm>
     </dsp:sp>
     <dsp:sp modelId="{13F65213-867A-4369-9543-F3799FB5E0F8}">
@@ -13146,8 +13238,8 @@
       </dsp:nvSpPr>
       <dsp:spPr>
         <a:xfrm>
-          <a:off x="2972679" y="4129914"/>
-          <a:ext cx="1440302" cy="1440302"/>
+          <a:off x="4185792" y="4632154"/>
+          <a:ext cx="1356269" cy="1356269"/>
         </a:xfrm>
         <a:prstGeom prst="ellipse">
           <a:avLst/>
@@ -13229,7 +13321,14 @@
             <a:buNone/>
           </a:pPr>
           <a:r>
-            <a:rPr lang="en-US" sz="1400" b="0" i="0" kern="1200" dirty="0"/>
+            <a:rPr lang="en-US" sz="1800" b="1" i="0" kern="1200" dirty="0">
+              <a:solidFill>
+                <a:prstClr val="white"/>
+              </a:solidFill>
+              <a:latin typeface="Amasis MT Pro Black" panose="020F0502020204030204" pitchFamily="18" charset="0"/>
+              <a:ea typeface="+mn-ea"/>
+              <a:cs typeface="+mn-cs"/>
+            </a:rPr>
             <a:t>✓</a:t>
           </a:r>
           <a:r>
@@ -13246,8 +13345,8 @@
         </a:p>
       </dsp:txBody>
       <dsp:txXfrm>
-        <a:off x="3183606" y="4340841"/>
-        <a:ext cx="1018448" cy="1018448"/>
+        <a:off x="4384413" y="4830775"/>
+        <a:ext cx="959027" cy="959027"/>
       </dsp:txXfrm>
     </dsp:sp>
     <dsp:sp modelId="{18CBF4D6-765C-4365-B23D-911EEF96DF4B}">
@@ -13256,9 +13355,9 @@
         <dsp:cNvSpPr/>
       </dsp:nvSpPr>
       <dsp:spPr>
-        <a:xfrm rot="10028571">
-          <a:off x="3216269" y="3128901"/>
-          <a:ext cx="721467" cy="27992"/>
+        <a:xfrm rot="8100000">
+          <a:off x="3575729" y="3808521"/>
+          <a:ext cx="947432" cy="25095"/>
         </a:xfrm>
         <a:custGeom>
           <a:avLst/>
@@ -13269,10 +13368,10 @@
           <a:pathLst>
             <a:path>
               <a:moveTo>
-                <a:pt x="0" y="13996"/>
+                <a:pt x="0" y="12547"/>
               </a:moveTo>
               <a:lnTo>
-                <a:pt x="721467" y="13996"/>
+                <a:pt x="947432" y="12547"/>
               </a:lnTo>
             </a:path>
           </a:pathLst>
@@ -13326,8 +13425,8 @@
         </a:p>
       </dsp:txBody>
       <dsp:txXfrm rot="10800000">
-        <a:off x="3558966" y="3124861"/>
-        <a:ext cx="36073" cy="36073"/>
+        <a:off x="4025760" y="3797383"/>
+        <a:ext cx="47371" cy="47371"/>
       </dsp:txXfrm>
     </dsp:sp>
     <dsp:sp modelId="{8726FD26-0446-4A34-A789-F609EFF6B576}">
@@ -13337,8 +13436,8 @@
       </dsp:nvSpPr>
       <dsp:spPr>
         <a:xfrm>
-          <a:off x="1803066" y="2663266"/>
-          <a:ext cx="1440302" cy="1440302"/>
+          <a:off x="2556829" y="3957416"/>
+          <a:ext cx="1356269" cy="1356269"/>
         </a:xfrm>
         <a:prstGeom prst="ellipse">
           <a:avLst/>
@@ -13413,15 +13512,21 @@
             <a:buNone/>
           </a:pPr>
           <a:r>
-            <a:rPr lang="en-US" sz="1400" b="0" i="0" kern="1200" dirty="0"/>
+            <a:rPr lang="en-US" sz="1800" b="1" i="0" kern="1200" dirty="0">
+              <a:solidFill>
+                <a:prstClr val="white"/>
+              </a:solidFill>
+              <a:latin typeface="Amasis MT Pro Black" panose="020F0502020204030204" pitchFamily="18" charset="0"/>
+              <a:ea typeface="+mn-ea"/>
+              <a:cs typeface="+mn-cs"/>
+            </a:rPr>
             <a:t>✓</a:t>
           </a:r>
-          <a:endParaRPr lang="en-US" sz="1400" b="1" kern="1200" dirty="0"/>
         </a:p>
       </dsp:txBody>
       <dsp:txXfrm>
-        <a:off x="2013993" y="2874193"/>
-        <a:ext cx="1018448" cy="1018448"/>
+        <a:off x="2755450" y="4156037"/>
+        <a:ext cx="959027" cy="959027"/>
       </dsp:txXfrm>
     </dsp:sp>
     <dsp:sp modelId="{0B890D38-9A63-42F6-B391-F93CB128C0AE}">
@@ -13430,9 +13535,9 @@
         <dsp:cNvSpPr/>
       </dsp:nvSpPr>
       <dsp:spPr>
-        <a:xfrm rot="13114286">
-          <a:off x="3424984" y="2214461"/>
-          <a:ext cx="721467" cy="27992"/>
+        <a:xfrm rot="10800000">
+          <a:off x="3238360" y="2994039"/>
+          <a:ext cx="947432" cy="25095"/>
         </a:xfrm>
         <a:custGeom>
           <a:avLst/>
@@ -13443,10 +13548,10 @@
           <a:pathLst>
             <a:path>
               <a:moveTo>
-                <a:pt x="0" y="13996"/>
+                <a:pt x="0" y="12547"/>
               </a:moveTo>
               <a:lnTo>
-                <a:pt x="721467" y="13996"/>
+                <a:pt x="947432" y="12547"/>
               </a:lnTo>
             </a:path>
           </a:pathLst>
@@ -13500,8 +13605,8 @@
         </a:p>
       </dsp:txBody>
       <dsp:txXfrm rot="10800000">
-        <a:off x="3767681" y="2210420"/>
-        <a:ext cx="36073" cy="36073"/>
+        <a:off x="3688390" y="2982901"/>
+        <a:ext cx="47371" cy="47371"/>
       </dsp:txXfrm>
     </dsp:sp>
     <dsp:sp modelId="{01EEE674-D7A4-44BB-95E6-EEE4B45DB353}">
@@ -13511,14 +13616,194 @@
       </dsp:nvSpPr>
       <dsp:spPr>
         <a:xfrm>
-          <a:off x="2220496" y="834385"/>
-          <a:ext cx="1440302" cy="1440302"/>
+          <a:off x="1882090" y="2328452"/>
+          <a:ext cx="1356269" cy="1356269"/>
         </a:xfrm>
         <a:prstGeom prst="ellipse">
           <a:avLst/>
         </a:prstGeom>
         <a:solidFill>
-          <a:schemeClr val="bg2">
+          <a:schemeClr val="accent6"/>
+        </a:solidFill>
+        <a:ln w="19050" cap="flat" cmpd="sng" algn="ctr">
+          <a:solidFill>
+            <a:schemeClr val="lt1">
+              <a:hueOff val="0"/>
+              <a:satOff val="0"/>
+              <a:lumOff val="0"/>
+              <a:alphaOff val="0"/>
+            </a:schemeClr>
+          </a:solidFill>
+          <a:prstDash val="solid"/>
+          <a:miter lim="800000"/>
+        </a:ln>
+        <a:effectLst/>
+      </dsp:spPr>
+      <dsp:style>
+        <a:lnRef idx="2">
+          <a:scrgbClr r="0" g="0" b="0"/>
+        </a:lnRef>
+        <a:fillRef idx="1">
+          <a:scrgbClr r="0" g="0" b="0"/>
+        </a:fillRef>
+        <a:effectRef idx="0">
+          <a:scrgbClr r="0" g="0" b="0"/>
+        </a:effectRef>
+        <a:fontRef idx="minor">
+          <a:schemeClr val="lt1"/>
+        </a:fontRef>
+      </dsp:style>
+      <dsp:txBody>
+        <a:bodyPr spcFirstLastPara="0" vert="horz" wrap="square" lIns="8890" tIns="8890" rIns="8890" bIns="8890" numCol="1" spcCol="1270" anchor="ctr" anchorCtr="0">
+          <a:noAutofit/>
+        </a:bodyPr>
+        <a:lstStyle/>
+        <a:p>
+          <a:pPr marL="0" lvl="0" indent="0" algn="ctr" defTabSz="622300">
+            <a:lnSpc>
+              <a:spcPct val="90000"/>
+            </a:lnSpc>
+            <a:spcBef>
+              <a:spcPct val="0"/>
+            </a:spcBef>
+            <a:spcAft>
+              <a:spcPct val="35000"/>
+            </a:spcAft>
+            <a:buFont typeface="+mj-lt"/>
+            <a:buNone/>
+          </a:pPr>
+          <a:r>
+            <a:rPr lang="en-US" sz="1400" b="1" kern="1200" dirty="0"/>
+            <a:t>Spatial Resolution </a:t>
+          </a:r>
+        </a:p>
+        <a:p>
+          <a:pPr marL="0" lvl="0" indent="0" algn="ctr" defTabSz="622300">
+            <a:lnSpc>
+              <a:spcPct val="90000"/>
+            </a:lnSpc>
+            <a:spcBef>
+              <a:spcPct val="0"/>
+            </a:spcBef>
+            <a:spcAft>
+              <a:spcPct val="35000"/>
+            </a:spcAft>
+            <a:buFont typeface="+mj-lt"/>
+            <a:buNone/>
+          </a:pPr>
+          <a:r>
+            <a:rPr lang="en-US" sz="1800" b="1" i="0" kern="1200" dirty="0">
+              <a:solidFill>
+                <a:prstClr val="white"/>
+              </a:solidFill>
+              <a:latin typeface="Amasis MT Pro Black" panose="020F0502020204030204" pitchFamily="18" charset="0"/>
+              <a:ea typeface="+mn-ea"/>
+              <a:cs typeface="+mn-cs"/>
+            </a:rPr>
+            <a:t>✓</a:t>
+          </a:r>
+        </a:p>
+      </dsp:txBody>
+      <dsp:txXfrm>
+        <a:off x="2080711" y="2527073"/>
+        <a:ext cx="959027" cy="959027"/>
+      </dsp:txXfrm>
+    </dsp:sp>
+    <dsp:sp modelId="{3B9E1353-2632-4497-81E7-C879A35F94AC}">
+      <dsp:nvSpPr>
+        <dsp:cNvPr id="0" name=""/>
+        <dsp:cNvSpPr/>
+      </dsp:nvSpPr>
+      <dsp:spPr>
+        <a:xfrm rot="13500000">
+          <a:off x="3575729" y="2179557"/>
+          <a:ext cx="947432" cy="25095"/>
+        </a:xfrm>
+        <a:custGeom>
+          <a:avLst/>
+          <a:gdLst/>
+          <a:ahLst/>
+          <a:cxnLst/>
+          <a:rect l="0" t="0" r="0" b="0"/>
+          <a:pathLst>
+            <a:path>
+              <a:moveTo>
+                <a:pt x="0" y="12547"/>
+              </a:moveTo>
+              <a:lnTo>
+                <a:pt x="947432" y="12547"/>
+              </a:lnTo>
+            </a:path>
+          </a:pathLst>
+        </a:custGeom>
+        <a:noFill/>
+        <a:ln w="19050" cap="flat" cmpd="sng" algn="ctr">
+          <a:solidFill>
+            <a:schemeClr val="accent5">
+              <a:hueOff val="0"/>
+              <a:satOff val="0"/>
+              <a:lumOff val="0"/>
+              <a:alphaOff val="0"/>
+            </a:schemeClr>
+          </a:solidFill>
+          <a:prstDash val="solid"/>
+          <a:miter lim="800000"/>
+        </a:ln>
+        <a:effectLst/>
+      </dsp:spPr>
+      <dsp:style>
+        <a:lnRef idx="2">
+          <a:scrgbClr r="0" g="0" b="0"/>
+        </a:lnRef>
+        <a:fillRef idx="0">
+          <a:scrgbClr r="0" g="0" b="0"/>
+        </a:fillRef>
+        <a:effectRef idx="0">
+          <a:scrgbClr r="0" g="0" b="0"/>
+        </a:effectRef>
+        <a:fontRef idx="minor"/>
+      </dsp:style>
+      <dsp:txBody>
+        <a:bodyPr spcFirstLastPara="0" vert="horz" wrap="square" lIns="12700" tIns="0" rIns="12700" bIns="0" numCol="1" spcCol="1270" anchor="ctr" anchorCtr="0">
+          <a:noAutofit/>
+        </a:bodyPr>
+        <a:lstStyle/>
+        <a:p>
+          <a:pPr marL="0" lvl="0" indent="0" algn="ctr" defTabSz="222250">
+            <a:lnSpc>
+              <a:spcPct val="90000"/>
+            </a:lnSpc>
+            <a:spcBef>
+              <a:spcPct val="0"/>
+            </a:spcBef>
+            <a:spcAft>
+              <a:spcPct val="35000"/>
+            </a:spcAft>
+            <a:buNone/>
+          </a:pPr>
+          <a:endParaRPr lang="en-US" sz="500" kern="1200"/>
+        </a:p>
+      </dsp:txBody>
+      <dsp:txXfrm rot="10800000">
+        <a:off x="4025760" y="2168420"/>
+        <a:ext cx="47371" cy="47371"/>
+      </dsp:txXfrm>
+    </dsp:sp>
+    <dsp:sp modelId="{53DB598F-3538-45FC-A34A-6E2175D70F64}">
+      <dsp:nvSpPr>
+        <dsp:cNvPr id="0" name=""/>
+        <dsp:cNvSpPr/>
+      </dsp:nvSpPr>
+      <dsp:spPr>
+        <a:xfrm>
+          <a:off x="2556829" y="699489"/>
+          <a:ext cx="1356269" cy="1356269"/>
+        </a:xfrm>
+        <a:prstGeom prst="ellipse">
+          <a:avLst/>
+        </a:prstGeom>
+        <a:solidFill>
+          <a:schemeClr val="bg1">
             <a:lumMod val="75000"/>
           </a:schemeClr>
         </a:solidFill>
@@ -13571,13 +13856,13 @@
           </a:pPr>
           <a:r>
             <a:rPr lang="en-US" sz="1400" b="1" kern="1200" dirty="0"/>
-            <a:t>Spatial Resolution </a:t>
+            <a:t>LF DAS</a:t>
           </a:r>
         </a:p>
       </dsp:txBody>
       <dsp:txXfrm>
-        <a:off x="2431423" y="1045312"/>
-        <a:ext cx="1018448" cy="1018448"/>
+        <a:off x="2755450" y="898110"/>
+        <a:ext cx="959027" cy="959027"/>
       </dsp:txXfrm>
     </dsp:sp>
   </dsp:spTree>
@@ -21112,7 +21397,7 @@
           <a:p>
             <a:fld id="{64AF2E3A-0E65-479D-A5E3-03C6FE5A6CB0}" type="datetimeFigureOut">
               <a:rPr lang="en-US" smtClean="0"/>
-              <a:t>2/20/2026</a:t>
+              <a:t>3/21/2026</a:t>
             </a:fld>
             <a:endParaRPr lang="en-US"/>
           </a:p>
@@ -21310,7 +21595,7 @@
           <a:p>
             <a:fld id="{64AF2E3A-0E65-479D-A5E3-03C6FE5A6CB0}" type="datetimeFigureOut">
               <a:rPr lang="en-US" smtClean="0"/>
-              <a:t>2/20/2026</a:t>
+              <a:t>3/21/2026</a:t>
             </a:fld>
             <a:endParaRPr lang="en-US"/>
           </a:p>
@@ -21518,7 +21803,7 @@
           <a:p>
             <a:fld id="{64AF2E3A-0E65-479D-A5E3-03C6FE5A6CB0}" type="datetimeFigureOut">
               <a:rPr lang="en-US" smtClean="0"/>
-              <a:t>2/20/2026</a:t>
+              <a:t>3/21/2026</a:t>
             </a:fld>
             <a:endParaRPr lang="en-US"/>
           </a:p>
@@ -21716,7 +22001,7 @@
           <a:p>
             <a:fld id="{64AF2E3A-0E65-479D-A5E3-03C6FE5A6CB0}" type="datetimeFigureOut">
               <a:rPr lang="en-US" smtClean="0"/>
-              <a:t>2/20/2026</a:t>
+              <a:t>3/21/2026</a:t>
             </a:fld>
             <a:endParaRPr lang="en-US"/>
           </a:p>
@@ -22021,7 +22306,7 @@
           <a:p>
             <a:fld id="{64AF2E3A-0E65-479D-A5E3-03C6FE5A6CB0}" type="datetimeFigureOut">
               <a:rPr lang="en-US" smtClean="0"/>
-              <a:t>2/20/2026</a:t>
+              <a:t>3/21/2026</a:t>
             </a:fld>
             <a:endParaRPr lang="en-US"/>
           </a:p>
@@ -22286,7 +22571,7 @@
           <a:p>
             <a:fld id="{64AF2E3A-0E65-479D-A5E3-03C6FE5A6CB0}" type="datetimeFigureOut">
               <a:rPr lang="en-US" smtClean="0"/>
-              <a:t>2/20/2026</a:t>
+              <a:t>3/21/2026</a:t>
             </a:fld>
             <a:endParaRPr lang="en-US"/>
           </a:p>
@@ -22698,7 +22983,7 @@
           <a:p>
             <a:fld id="{64AF2E3A-0E65-479D-A5E3-03C6FE5A6CB0}" type="datetimeFigureOut">
               <a:rPr lang="en-US" smtClean="0"/>
-              <a:t>2/20/2026</a:t>
+              <a:t>3/21/2026</a:t>
             </a:fld>
             <a:endParaRPr lang="en-US"/>
           </a:p>
@@ -22839,7 +23124,7 @@
           <a:p>
             <a:fld id="{64AF2E3A-0E65-479D-A5E3-03C6FE5A6CB0}" type="datetimeFigureOut">
               <a:rPr lang="en-US" smtClean="0"/>
-              <a:t>2/20/2026</a:t>
+              <a:t>3/21/2026</a:t>
             </a:fld>
             <a:endParaRPr lang="en-US"/>
           </a:p>
@@ -22952,7 +23237,7 @@
           <a:p>
             <a:fld id="{64AF2E3A-0E65-479D-A5E3-03C6FE5A6CB0}" type="datetimeFigureOut">
               <a:rPr lang="en-US" smtClean="0"/>
-              <a:t>2/20/2026</a:t>
+              <a:t>3/21/2026</a:t>
             </a:fld>
             <a:endParaRPr lang="en-US"/>
           </a:p>
@@ -23263,7 +23548,7 @@
           <a:p>
             <a:fld id="{64AF2E3A-0E65-479D-A5E3-03C6FE5A6CB0}" type="datetimeFigureOut">
               <a:rPr lang="en-US" smtClean="0"/>
-              <a:t>2/20/2026</a:t>
+              <a:t>3/21/2026</a:t>
             </a:fld>
             <a:endParaRPr lang="en-US"/>
           </a:p>
@@ -23551,7 +23836,7 @@
           <a:p>
             <a:fld id="{64AF2E3A-0E65-479D-A5E3-03C6FE5A6CB0}" type="datetimeFigureOut">
               <a:rPr lang="en-US" smtClean="0"/>
-              <a:t>2/20/2026</a:t>
+              <a:t>3/21/2026</a:t>
             </a:fld>
             <a:endParaRPr lang="en-US"/>
           </a:p>
@@ -23792,7 +24077,7 @@
           <a:p>
             <a:fld id="{64AF2E3A-0E65-479D-A5E3-03C6FE5A6CB0}" type="datetimeFigureOut">
               <a:rPr lang="en-US" smtClean="0"/>
-              <a:t>2/20/2026</a:t>
+              <a:t>3/21/2026</a:t>
             </a:fld>
             <a:endParaRPr lang="en-US"/>
           </a:p>
@@ -26713,8 +26998,8 @@
         </p:nvGrpSpPr>
         <p:grpSpPr>
           <a:xfrm>
-            <a:off x="1319719" y="712745"/>
-            <a:ext cx="9261576" cy="5590674"/>
+            <a:off x="853440" y="712745"/>
+            <a:ext cx="9727855" cy="6013175"/>
             <a:chOff x="1319719" y="712745"/>
             <a:chExt cx="9261576" cy="5590674"/>
           </a:xfrm>
@@ -26732,7 +27017,7 @@
             <p:nvPr>
               <p:extLst>
                 <p:ext uri="{D42A27DB-BD31-4B8C-83A1-F6EECF244321}">
-                  <p14:modId xmlns:p14="http://schemas.microsoft.com/office/powerpoint/2010/main" val="2692833470"/>
+                  <p14:modId xmlns:p14="http://schemas.microsoft.com/office/powerpoint/2010/main" val="3086716862"/>
                 </p:ext>
               </p:extLst>
             </p:nvPr>
@@ -26776,7 +27061,7 @@
           </p:blipFill>
           <p:spPr bwMode="auto">
             <a:xfrm rot="18752489" flipH="1">
-              <a:off x="5248221" y="2906050"/>
+              <a:off x="5204692" y="2783250"/>
               <a:ext cx="1322780" cy="1322780"/>
             </a:xfrm>
             <a:prstGeom prst="rect">

</xml_diff>